<commit_message>
feat(livrables): placeholders jaunes + titre + resume sans chiffres + serveur reel + kit toute-machine + QA progressive + cleanup repo
</commit_message>
<xml_diff>
--- a/book/soutenance.pptx
+++ b/book/soutenance.pptx
@@ -2551,7 +2551,7 @@
           <a:p>
             <a:r>
               <a:rPr lang="en-US" dirty="0"/>
-              <a:t>L'outil tient dans un seul binaire : il se copie, il se lance, tout est dedans. Treize virgule sept mégaoctets mesurés. Chaque mesure est gelée avec son empreinte SHA-256 : n'importe quel lecteur peut vérifier que les fichiers n'ont pas bougé. Et le banc survit aux coupures de courant.</a:t>
+              <a:t>L'outil tient dans un seul binaire : il se copie, il se lance, tout est dedans. Chaque mesure est gelée avec son empreinte SHA-256 : n'importe quel lecteur peut vérifier que les fichiers n'ont pas bougé. Et le banc survit aux coupures de courant.</a:t>
             </a:r>
             <a:endParaRPr lang="en-US" dirty="0"/>
           </a:p>
@@ -16278,7 +16278,7 @@
                 <a:ea typeface="Arial" pitchFamily="34" charset="-122"/>
                 <a:cs typeface="Arial" pitchFamily="34" charset="-120"/>
               </a:rPr>
-              <a:t>13,7 Mo</a:t>
+              <a:t>1 fichier</a:t>
             </a:r>
             <a:endParaRPr lang="en-US" sz="4200" dirty="0"/>
           </a:p>
@@ -16320,7 +16320,7 @@
                 <a:ea typeface="Arial" pitchFamily="34" charset="-122"/>
                 <a:cs typeface="Arial" pitchFamily="34" charset="-120"/>
               </a:rPr>
-              <a:t>BINAIRE STATIQUE MESURÉ, FRONTEND WEB EMBARQUÉ</a:t>
+              <a:t>BINAIRE STATIQUE, FRONTEND WEB EMBARQUÉ</a:t>
             </a:r>
             <a:endParaRPr lang="en-US" sz="1250" dirty="0"/>
           </a:p>
@@ -16359,7 +16359,7 @@
                 <a:ea typeface="Arial" pitchFamily="34" charset="-122"/>
                 <a:cs typeface="Arial" pitchFamily="34" charset="-120"/>
               </a:rPr>
-              <a:t>4 Go</a:t>
+              <a:t>Serveur réel</a:t>
             </a:r>
             <a:endParaRPr lang="en-US" sz="4200" dirty="0"/>
           </a:p>
@@ -16401,7 +16401,7 @@
                 <a:ea typeface="Arial" pitchFamily="34" charset="-122"/>
                 <a:cs typeface="Arial" pitchFamily="34" charset="-120"/>
               </a:rPr>
-              <a:t>SERVEUR DU BANC : UBUNTU SERVER 24.04 LTS</a:t>
+              <a:t>MACHINE PHYSIQUE MÉTÉO MADAGASCAR : UBUNTU SERVER</a:t>
             </a:r>
             <a:endParaRPr lang="en-US" sz="1250" dirty="0"/>
           </a:p>

</xml_diff>